<commit_message>
update Intro lectures to reflect 2026 running
</commit_message>
<xml_diff>
--- a/slides/Lecture_01_Intro.pptx
+++ b/slides/Lecture_01_Intro.pptx
@@ -204,7 +204,7 @@
           <a:p>
             <a:fld id="{92C08CDA-29C6-4C4F-9345-278F31C990CA}" type="datetimeFigureOut">
               <a:rPr lang="en-GB" smtClean="0"/>
-              <a:t>09/09/2024</a:t>
+              <a:t>26/08/2026</a:t>
             </a:fld>
             <a:endParaRPr lang="en-GB"/>
           </a:p>
@@ -2887,6 +2887,34 @@
                 <a:ea typeface="Open Sans" panose="020B0606030504020204" pitchFamily="34" charset="0"/>
                 <a:cs typeface="Open Sans" panose="020B0606030504020204" pitchFamily="34" charset="0"/>
               </a:rPr>
+              <a:t>Katie Atkins, PhD </a:t>
+            </a:r>
+            <a:r>
+              <a:rPr lang="en-GB" sz="2000" dirty="0">
+                <a:latin typeface="Open Sans" panose="020B0606030504020204" pitchFamily="34" charset="0"/>
+                <a:ea typeface="Open Sans" panose="020B0606030504020204" pitchFamily="34" charset="0"/>
+                <a:cs typeface="Open Sans" panose="020B0606030504020204" pitchFamily="34" charset="0"/>
+                <a:hlinkClick r:id="rId2"/>
+              </a:rPr>
+              <a:t>Katherine.Atkins@lshtm.ac.uk</a:t>
+            </a:r>
+            <a:endParaRPr lang="en-GB" sz="2000" dirty="0">
+              <a:latin typeface="Open Sans" panose="020B0606030504020204" pitchFamily="34" charset="0"/>
+              <a:ea typeface="Open Sans" panose="020B0606030504020204" pitchFamily="34" charset="0"/>
+              <a:cs typeface="Open Sans" panose="020B0606030504020204" pitchFamily="34" charset="0"/>
+            </a:endParaRPr>
+          </a:p>
+          <a:p>
+            <a:pPr marL="285750" indent="-285750">
+              <a:buFont typeface="Arial" panose="020B0604020202020204" pitchFamily="34" charset="0"/>
+              <a:buChar char="•"/>
+            </a:pPr>
+            <a:r>
+              <a:rPr lang="en-GB" sz="2000" dirty="0">
+                <a:latin typeface="Open Sans" panose="020B0606030504020204" pitchFamily="34" charset="0"/>
+                <a:ea typeface="Open Sans" panose="020B0606030504020204" pitchFamily="34" charset="0"/>
+                <a:cs typeface="Open Sans" panose="020B0606030504020204" pitchFamily="34" charset="0"/>
+              </a:rPr>
               <a:t>Nicholas Davies, PhD </a:t>
             </a:r>
             <a:r>
@@ -2898,7 +2926,7 @@
                 <a:latin typeface="Open Sans" panose="020B0606030504020204" pitchFamily="34" charset="0"/>
                 <a:ea typeface="Open Sans" panose="020B0606030504020204" pitchFamily="34" charset="0"/>
                 <a:cs typeface="Open Sans" panose="020B0606030504020204" pitchFamily="34" charset="0"/>
-                <a:hlinkClick r:id="rId2"/>
+                <a:hlinkClick r:id="rId3"/>
               </a:rPr>
               <a:t>Nicholas.Davies@lshtm.ac.uk</a:t>
             </a:r>
@@ -2923,7 +2951,7 @@
                 <a:ea typeface="Open Sans" panose="020B0606030504020204" pitchFamily="34" charset="0"/>
                 <a:cs typeface="Open Sans" panose="020B0606030504020204" pitchFamily="34" charset="0"/>
               </a:rPr>
-              <a:t>Yang Liu, PhD </a:t>
+              <a:t>Roz Eggo, PhD </a:t>
             </a:r>
             <a:r>
               <a:rPr lang="en-GB" sz="2000" dirty="0">
@@ -2933,9 +2961,9 @@
                 <a:latin typeface="Open Sans" panose="020B0606030504020204" pitchFamily="34" charset="0"/>
                 <a:ea typeface="Open Sans" panose="020B0606030504020204" pitchFamily="34" charset="0"/>
                 <a:cs typeface="Open Sans" panose="020B0606030504020204" pitchFamily="34" charset="0"/>
-                <a:hlinkClick r:id="rId3"/>
+                <a:hlinkClick r:id="rId4"/>
               </a:rPr>
-              <a:t>Yang.Liu@lshtm.ac.uk</a:t>
+              <a:t>Roz.Eggo@lshtm.ac.uk</a:t>
             </a:r>
             <a:endParaRPr lang="en-GB" sz="2000" dirty="0">
               <a:solidFill>
@@ -2957,16 +2985,16 @@
                 <a:ea typeface="Open Sans" panose="020B0606030504020204" pitchFamily="34" charset="0"/>
                 <a:cs typeface="Open Sans" panose="020B0606030504020204" pitchFamily="34" charset="0"/>
               </a:rPr>
-              <a:t>Oli Brady, PhD </a:t>
+              <a:t>Kaitlyn Johnson, PhD </a:t>
             </a:r>
             <a:r>
               <a:rPr lang="en-GB" sz="2000" dirty="0">
                 <a:latin typeface="Open Sans" panose="020B0606030504020204" pitchFamily="34" charset="0"/>
                 <a:ea typeface="Open Sans" panose="020B0606030504020204" pitchFamily="34" charset="0"/>
                 <a:cs typeface="Open Sans" panose="020B0606030504020204" pitchFamily="34" charset="0"/>
-                <a:hlinkClick r:id="rId4"/>
+                <a:hlinkClick r:id="rId5"/>
               </a:rPr>
-              <a:t>Oliver.Brady@lshtm.ac.uk</a:t>
+              <a:t>Kaitlyn.Johnson@lshtm.ac.uk</a:t>
             </a:r>
             <a:r>
               <a:rPr lang="en-GB" sz="2000" dirty="0">
@@ -3028,7 +3056,7 @@
                 <a:latin typeface="Open Sans" panose="020B0606030504020204" pitchFamily="34" charset="0"/>
                 <a:ea typeface="Open Sans" panose="020B0606030504020204" pitchFamily="34" charset="0"/>
                 <a:cs typeface="Open Sans" panose="020B0606030504020204" pitchFamily="34" charset="0"/>
-                <a:hlinkClick r:id="rId5"/>
+                <a:hlinkClick r:id="rId6"/>
               </a:rPr>
               <a:t>Francesco.Grisolia@lshtm.ac.uk</a:t>
             </a:r>
@@ -3066,39 +3094,7 @@
                 <a:ea typeface="Open Sans" panose="020B0606030504020204" pitchFamily="34" charset="0"/>
                 <a:cs typeface="Open Sans" panose="020B0606030504020204" pitchFamily="34" charset="0"/>
               </a:rPr>
-              <a:t>Billy </a:t>
-            </a:r>
-            <a:r>
-              <a:rPr lang="en-GB" sz="2000" dirty="0" err="1">
-                <a:latin typeface="Open Sans" panose="020B0606030504020204" pitchFamily="34" charset="0"/>
-                <a:ea typeface="Open Sans" panose="020B0606030504020204" pitchFamily="34" charset="0"/>
-                <a:cs typeface="Open Sans" panose="020B0606030504020204" pitchFamily="34" charset="0"/>
-              </a:rPr>
-              <a:t>Quilty</a:t>
-            </a:r>
-            <a:r>
-              <a:rPr lang="en-GB" sz="2000" dirty="0">
-                <a:latin typeface="Open Sans" panose="020B0606030504020204" pitchFamily="34" charset="0"/>
-                <a:ea typeface="Open Sans" panose="020B0606030504020204" pitchFamily="34" charset="0"/>
-                <a:cs typeface="Open Sans" panose="020B0606030504020204" pitchFamily="34" charset="0"/>
-              </a:rPr>
-              <a:t>, Kath O’Reilly, Seb Funk, Johnny Filipe, Alexis Robert, Alex Richards, </a:t>
-            </a:r>
-            <a:r>
-              <a:rPr lang="en-GB" sz="2000" dirty="0" err="1">
-                <a:latin typeface="Open Sans" panose="020B0606030504020204" pitchFamily="34" charset="0"/>
-                <a:ea typeface="Open Sans" panose="020B0606030504020204" pitchFamily="34" charset="0"/>
-                <a:cs typeface="Open Sans" panose="020B0606030504020204" pitchFamily="34" charset="0"/>
-              </a:rPr>
-              <a:t>Kaja</a:t>
-            </a:r>
-            <a:r>
-              <a:rPr lang="en-GB" sz="2000" dirty="0">
-                <a:latin typeface="Open Sans" panose="020B0606030504020204" pitchFamily="34" charset="0"/>
-                <a:ea typeface="Open Sans" panose="020B0606030504020204" pitchFamily="34" charset="0"/>
-                <a:cs typeface="Open Sans" panose="020B0606030504020204" pitchFamily="34" charset="0"/>
-              </a:rPr>
-              <a:t> Abbas (All LSHTM / CMMID-based)</a:t>
+              <a:t>Sam Abbott, Alexis Robert, Kaja Abbas (All LSHTM / CMMID-based)</a:t>
             </a:r>
           </a:p>
         </p:txBody>
@@ -3422,7 +3418,7 @@
             </a:pPr>
             <a:r>
               <a:rPr lang="en-GB" sz="2000" dirty="0"/>
-              <a:t>The days will run ~10-4pm (London) each day, with regular comfort breaks</a:t>
+              <a:t>The days will run ~10-4.30/5pm (London) each day, with regular comfort breaks</a:t>
             </a:r>
           </a:p>
           <a:p>
@@ -3431,7 +3427,7 @@
               <a:buChar char="•"/>
             </a:pPr>
             <a:r>
-              <a:rPr lang="en-GB" sz="2000">
+              <a:rPr lang="en-GB" sz="2000" dirty="0">
                 <a:latin typeface="Open Sans" panose="020B0606030504020204" pitchFamily="34" charset="0"/>
                 <a:ea typeface="Open Sans" panose="020B0606030504020204" pitchFamily="34" charset="0"/>
                 <a:cs typeface="Open Sans" panose="020B0606030504020204" pitchFamily="34" charset="0"/>
@@ -3529,7 +3525,7 @@
                 <a:ea typeface="Open Sans" panose="020B0606030504020204" pitchFamily="34" charset="0"/>
                 <a:cs typeface="Open Sans" panose="020B0606030504020204" pitchFamily="34" charset="0"/>
               </a:rPr>
-              <a:t>When in breakout groups please keep cameras on when possible to encourage discussion</a:t>
+              <a:t>Please keep cameras on when possible to encourage discussion</a:t>
             </a:r>
             <a:br>
               <a:rPr lang="en-GB" sz="2301" dirty="0">
@@ -3777,7 +3773,7 @@
             </a:br>
             <a:r>
               <a:rPr lang="en-GB" sz="1600" dirty="0"/>
-              <a:t>      (shout out now if you haven’t logged-in! Or cannot access </a:t>
+              <a:t>      (shout out now if you haven’t got access! Or cannot access </a:t>
             </a:r>
             <a:r>
               <a:rPr lang="en-GB" sz="1600" dirty="0" err="1"/>
@@ -4068,7 +4064,7 @@
             </a:pPr>
             <a:r>
               <a:rPr lang="en-GB" sz="1800" b="1" dirty="0"/>
-              <a:t>Monday</a:t>
+              <a:t>Tuesday</a:t>
             </a:r>
             <a:br>
               <a:rPr lang="en-GB" sz="1800" b="1" dirty="0"/>
@@ -4097,7 +4093,7 @@
             </a:pPr>
             <a:r>
               <a:rPr lang="en-GB" sz="1800" b="1" dirty="0"/>
-              <a:t>Tuesday</a:t>
+              <a:t>Wednesday</a:t>
             </a:r>
           </a:p>
           <a:p>
@@ -4133,7 +4129,7 @@
             </a:pPr>
             <a:r>
               <a:rPr lang="en-GB" sz="1800" b="1" dirty="0"/>
-              <a:t>Wednesday</a:t>
+              <a:t>Thursday</a:t>
             </a:r>
           </a:p>
           <a:p>
@@ -4159,7 +4155,7 @@
             </a:br>
             <a:r>
               <a:rPr lang="en-GB" sz="1800" b="1" dirty="0"/>
-              <a:t>Thursday</a:t>
+              <a:t>Friday</a:t>
             </a:r>
           </a:p>
           <a:p>

</xml_diff>